<commit_message>
PACCAR Q3 2026: plainer wording, drop the add-on-penalties clause
Remove 'not X but Y' and 'rather than' constructions and sentences opening
with 'What' (the two column heads stay), drop 'The quarter splits in two',
and cut 'and would add once the 2027 emission penalties are finalised'
from the base case.

Co-Authored-By: Claude Opus 5.5 <noreply@anthropic.com>
Claude-Session: https://claude.ai/code/session_0194roGR9gj46kR1yhWUsVf3
</commit_message>
<xml_diff>
--- a/reports/PCAR_Q3_2026/Earnings_Update_PCAR_Q32026.pptx
+++ b/reports/PCAR_Q3_2026/Earnings_Update_PCAR_Q32026.pptx
@@ -1698,7 +1698,7 @@
                 <a:ea typeface="Nunito" pitchFamily="34" charset="-122"/>
                 <a:cs typeface="Nunito" pitchFamily="34" charset="-120"/>
               </a:rPr>
-              <a:t>17.6x forward earnings, down from 23.9x in July while consensus EPS rose 3%: the derating looks done.</a:t>
+              <a:t>17.6x forward earnings, down from 23.9x in July while consensus EPS rose 3% over the same period.</a:t>
             </a:r>
             <a:endParaRPr lang="en-US" sz="870" dirty="0"/>
           </a:p>
@@ -2299,7 +2299,7 @@
                 <a:ea typeface="Nunito" pitchFamily="34" charset="-122"/>
                 <a:cs typeface="Nunito" pitchFamily="34" charset="-120"/>
               </a:rPr>
-              <a:t>Earnings are recovering, the multiple is not</a:t>
+              <a:t>Earnings recover as the multiple falls</a:t>
             </a:r>
             <a:endParaRPr lang="en-US" sz="1100" dirty="0"/>
           </a:p>
@@ -2341,7 +2341,7 @@
                 <a:ea typeface="Nunito" pitchFamily="34" charset="-122"/>
                 <a:cs typeface="Nunito" pitchFamily="34" charset="-120"/>
               </a:rPr>
-              <a:t>EPS of USD 1.61 met consensus and truck profit beat estimates by 43%, yet sales missed by 1.3% and the shares eased 0.6% on 27 October, a reaction in line with a mixed print. Earnings are recovering on truck margins rather than volume. What holds the stock back is not this print but the unresolved 2027 emission rules and the timing of a pull-forward.</a:t>
+              <a:t>EPS of USD 1.61 met consensus and truck profit beat estimates by 43%, yet sales missed by 1.3% and the shares eased 0.6% on 27 October, a reaction in line with a mixed print. Higher deliveries lifted the truck pretax margin to 8.1%. The stock is held back by the unresolved 2027 emission rules and the timing of a pull-forward in orders.</a:t>
             </a:r>
             <a:endParaRPr lang="en-US" sz="870" dirty="0"/>
           </a:p>
@@ -2502,7 +2502,7 @@
                 <a:ea typeface="Nunito" pitchFamily="34" charset="-122"/>
                 <a:cs typeface="Nunito" pitchFamily="34" charset="-120"/>
               </a:rPr>
-              <a:t>The quarter splits in two. Trucks delivered a 43% profit surprise on revenue up 28% year on year, a pretax margin of 8.1%. Parts, the steadiest earner, posted record revenue but pretax profit 14% below estimates. Supplier shortfalls cost about 1,900 deliveries against guidance, which we think explains most of the sales miss.</a:t>
+              <a:t>Trucks delivered a 43% profit surprise on revenue up 28% year on year, a pretax margin of 8.1%. Parts, the steadiest earner, posted record revenue of USD 1.78bn but pretax profit 14% below estimates. Supplier shortfalls cost about 1,900 deliveries against guidance, which we think explains most of the sales miss.</a:t>
             </a:r>
             <a:endParaRPr lang="en-US" sz="870" dirty="0"/>
           </a:p>
@@ -2556,7 +2556,7 @@
         <p:spPr>
           <a:xfrm>
             <a:off x="539496" y="7416607"/>
-            <a:ext cx="6483096" cy="802767"/>
+            <a:ext cx="6483096" cy="645871"/>
           </a:xfrm>
           <a:prstGeom prst="rect">
             <a:avLst/>
@@ -2583,7 +2583,7 @@
                 <a:ea typeface="Nunito" pitchFamily="34" charset="-122"/>
                 <a:cs typeface="Nunito" pitchFamily="34" charset="-120"/>
               </a:rPr>
-              <a:t>We keep the position and would add once the 2027 emission penalties are finalised. We underwrite consensus forward EPS of USD 5.90, 16% above a year ago and 34% below the 2023 peak, carried by truck margins and record Parts revenue. The debate has moved from the freight recession to the 2027 rules and the pull-forward. At 17.6x, the July premium is gone and sentiment is negative, which we think limits the downside. The next test is Q4 deliveries of 41,000 to 43,000, due in late January 2027.</a:t>
+              <a:t>We keep the position. We underwrite consensus forward EPS of USD 5.90, 16% above a year ago and 34% below the 2023 peak, carried by truck margins and record Parts revenue. The debate has moved from the freight recession to the 2027 rules and the size of a pull-forward in orders. At 17.6x, the July premium is gone and sentiment is negative, which we think limits the downside. The next test is Q4 deliveries of 41,000 to 43,000, due in late January 2027.</a:t>
             </a:r>
             <a:endParaRPr lang="en-US" sz="870" dirty="0"/>
           </a:p>
@@ -2597,7 +2597,7 @@
         </p:nvSpPr>
         <p:spPr>
           <a:xfrm>
-            <a:off x="3781044" y="8335503"/>
+            <a:off x="3781044" y="8178607"/>
             <a:ext cx="0" cy="828751"/>
           </a:xfrm>
           <a:prstGeom prst="line">
@@ -2620,7 +2620,7 @@
         </p:nvSpPr>
         <p:spPr>
           <a:xfrm>
-            <a:off x="539496" y="8335503"/>
+            <a:off x="539496" y="8178607"/>
             <a:ext cx="3058668" cy="155448"/>
           </a:xfrm>
           <a:prstGeom prst="rect">
@@ -2659,7 +2659,7 @@
         </p:nvSpPr>
         <p:spPr>
           <a:xfrm>
-            <a:off x="539496" y="8527527"/>
+            <a:off x="539496" y="8370631"/>
             <a:ext cx="3058668" cy="627583"/>
           </a:xfrm>
           <a:prstGeom prst="rect">
@@ -2701,7 +2701,7 @@
         </p:nvSpPr>
         <p:spPr>
           <a:xfrm>
-            <a:off x="3963924" y="8335503"/>
+            <a:off x="3963924" y="8178607"/>
             <a:ext cx="3058668" cy="155448"/>
           </a:xfrm>
           <a:prstGeom prst="rect">
@@ -2740,7 +2740,7 @@
         </p:nvSpPr>
         <p:spPr>
           <a:xfrm>
-            <a:off x="3963924" y="8527527"/>
+            <a:off x="3963924" y="8370631"/>
             <a:ext cx="3058668" cy="627583"/>
           </a:xfrm>
           <a:prstGeom prst="rect">

</xml_diff>